<commit_message>
Fix: 50 templates with correct shape names (title/content)
</commit_message>
<xml_diff>
--- a/template1.pptx
+++ b/template1.pptx
@@ -3091,7 +3091,7 @@
       <p:grpSpPr/>
       <p:sp>
         <p:nvSpPr>
-          <p:cNvPr id="2" name="Rectangle 1"/>
+          <p:cNvPr id="2" name="background"/>
           <p:cNvSpPr/>
           <p:nvPr/>
         </p:nvSpPr>
@@ -3134,14 +3134,14 @@
       </p:sp>
       <p:sp>
         <p:nvSpPr>
-          <p:cNvPr id="3" name="Rectangle 2"/>
+          <p:cNvPr id="3" name="accent_top"/>
           <p:cNvSpPr/>
           <p:nvPr/>
         </p:nvSpPr>
         <p:spPr>
           <a:xfrm>
             <a:off x="0" y="0"/>
-            <a:ext cx="12188952" cy="109728"/>
+            <a:ext cx="12188952" cy="137160"/>
           </a:xfrm>
           <a:prstGeom prst="rect">
             <a:avLst/>
@@ -3177,14 +3177,14 @@
       </p:sp>
       <p:sp>
         <p:nvSpPr>
-          <p:cNvPr id="4" name="Rectangle 3"/>
+          <p:cNvPr id="4" name="accent_bottom"/>
           <p:cNvSpPr/>
           <p:nvPr/>
         </p:nvSpPr>
         <p:spPr>
           <a:xfrm>
-            <a:off x="0" y="6748272"/>
-            <a:ext cx="12188952" cy="109728"/>
+            <a:off x="0" y="6720840"/>
+            <a:ext cx="12188952" cy="137160"/>
           </a:xfrm>
           <a:prstGeom prst="rect">
             <a:avLst/>
@@ -3220,14 +3220,14 @@
       </p:sp>
       <p:sp>
         <p:nvSpPr>
-          <p:cNvPr id="5" name="TextBox 4"/>
+          <p:cNvPr id="5" name="title"/>
           <p:cNvSpPr txBox="1"/>
           <p:nvPr/>
         </p:nvSpPr>
         <p:spPr>
           <a:xfrm>
-            <a:off x="731520" y="2286000"/>
-            <a:ext cx="10698480" cy="1371600"/>
+            <a:off x="914400" y="2011680"/>
+            <a:ext cx="10332720" cy="1645920"/>
           </a:xfrm>
           <a:prstGeom prst="rect">
             <a:avLst/>
@@ -3242,26 +3242,26 @@
           <a:p>
             <a:pPr algn="ctr"/>
             <a:r>
-              <a:rPr sz="3600" b="1">
+              <a:rPr sz="4000" b="1">
                 <a:solidFill>
                   <a:srgbClr val="FFFFFF"/>
                 </a:solidFill>
               </a:rPr>
-              <a:t>{{TITLE}}</a:t>
-            </a:r>
-          </a:p>
-        </p:txBody>
-      </p:sp>
-      <p:sp>
-        <p:nvSpPr>
-          <p:cNvPr id="6" name="TextBox 5"/>
+              <a:t>Mavzu sarlavhasi</a:t>
+            </a:r>
+          </a:p>
+        </p:txBody>
+      </p:sp>
+      <p:sp>
+        <p:nvSpPr>
+          <p:cNvPr id="6" name="content"/>
           <p:cNvSpPr txBox="1"/>
           <p:nvPr/>
         </p:nvSpPr>
         <p:spPr>
           <a:xfrm>
-            <a:off x="731520" y="3840480"/>
-            <a:ext cx="10698480" cy="731520"/>
+            <a:off x="914400" y="3840480"/>
+            <a:ext cx="10332720" cy="822960"/>
           </a:xfrm>
           <a:prstGeom prst="rect">
             <a:avLst/>
@@ -3269,19 +3269,19 @@
           <a:noFill/>
         </p:spPr>
         <p:txBody>
-          <a:bodyPr wrap="none">
+          <a:bodyPr wrap="square">
             <a:spAutoFit/>
           </a:bodyPr>
           <a:lstStyle/>
           <a:p>
             <a:pPr algn="ctr"/>
             <a:r>
-              <a:rPr sz="1800">
+              <a:rPr sz="2000">
                 <a:solidFill>
                   <a:srgbClr val="FFC800"/>
                 </a:solidFill>
               </a:rPr>
-              <a:t>{{SUBTITLE}}</a:t>
+              <a:t>Tayyorladi: Ism Familiya</a:t>
             </a:r>
           </a:p>
         </p:txBody>
@@ -3306,7 +3306,7 @@
       <p:grpSpPr/>
       <p:sp>
         <p:nvSpPr>
-          <p:cNvPr id="2" name="Rectangle 1"/>
+          <p:cNvPr id="2" name="background"/>
           <p:cNvSpPr/>
           <p:nvPr/>
         </p:nvSpPr>
@@ -3349,14 +3349,14 @@
       </p:sp>
       <p:sp>
         <p:nvSpPr>
-          <p:cNvPr id="3" name="Rectangle 2"/>
+          <p:cNvPr id="3" name="strip"/>
           <p:cNvSpPr/>
           <p:nvPr/>
         </p:nvSpPr>
         <p:spPr>
           <a:xfrm>
             <a:off x="0" y="0"/>
-            <a:ext cx="137160" cy="6858000"/>
+            <a:ext cx="164592" cy="6858000"/>
           </a:xfrm>
           <a:prstGeom prst="rect">
             <a:avLst/>
@@ -3392,14 +3392,14 @@
       </p:sp>
       <p:sp>
         <p:nvSpPr>
-          <p:cNvPr id="4" name="TextBox 3"/>
+          <p:cNvPr id="4" name="title"/>
           <p:cNvSpPr txBox="1"/>
           <p:nvPr/>
         </p:nvSpPr>
         <p:spPr>
           <a:xfrm>
-            <a:off x="365760" y="274320"/>
-            <a:ext cx="11430000" cy="822960"/>
+            <a:off x="365760" y="228600"/>
+            <a:ext cx="11612880" cy="914400"/>
           </a:xfrm>
           <a:prstGeom prst="rect">
             <a:avLst/>
@@ -3407,32 +3407,32 @@
           <a:noFill/>
         </p:spPr>
         <p:txBody>
-          <a:bodyPr wrap="none">
+          <a:bodyPr wrap="square">
             <a:spAutoFit/>
           </a:bodyPr>
           <a:lstStyle/>
           <a:p>
             <a:r>
-              <a:rPr sz="2800" b="1">
+              <a:rPr sz="3000" b="1">
                 <a:solidFill>
                   <a:srgbClr val="FFC800"/>
                 </a:solidFill>
               </a:rPr>
-              <a:t>{{SLIDE_TITLE}}</a:t>
-            </a:r>
-          </a:p>
-        </p:txBody>
-      </p:sp>
-      <p:sp>
-        <p:nvSpPr>
-          <p:cNvPr id="5" name="Rectangle 4"/>
+              <a:t>Slayd sarlavhasi</a:t>
+            </a:r>
+          </a:p>
+        </p:txBody>
+      </p:sp>
+      <p:sp>
+        <p:nvSpPr>
+          <p:cNvPr id="5" name="divider"/>
           <p:cNvSpPr/>
           <p:nvPr/>
         </p:nvSpPr>
         <p:spPr>
           <a:xfrm>
-            <a:off x="365760" y="1188720"/>
-            <a:ext cx="11430000" cy="36576"/>
+            <a:off x="365760" y="1234440"/>
+            <a:ext cx="11612880" cy="45720"/>
           </a:xfrm>
           <a:prstGeom prst="rect">
             <a:avLst/>
@@ -3468,14 +3468,14 @@
       </p:sp>
       <p:sp>
         <p:nvSpPr>
-          <p:cNvPr id="6" name="TextBox 5"/>
+          <p:cNvPr id="6" name="content"/>
           <p:cNvSpPr txBox="1"/>
           <p:nvPr/>
         </p:nvSpPr>
         <p:spPr>
           <a:xfrm>
             <a:off x="365760" y="1371600"/>
-            <a:ext cx="11430000" cy="5029200"/>
+            <a:ext cx="11612880" cy="5212080"/>
           </a:xfrm>
           <a:prstGeom prst="rect">
             <a:avLst/>
@@ -3489,12 +3489,12 @@
           <a:lstStyle/>
           <a:p>
             <a:r>
-              <a:rPr sz="1600">
+              <a:rPr sz="1800">
                 <a:solidFill>
-                  <a:srgbClr val="FFFFFF"/>
+                  <a:srgbClr val="DCEBFF"/>
                 </a:solidFill>
               </a:rPr>
-              <a:t>{{CONTENT}}</a:t>
+              <a:t>• Kontent matni shu yerda chiqadi</a:t>
             </a:r>
           </a:p>
         </p:txBody>

</xml_diff>